<commit_message>
Fix corrupted PPTX: avoid duplicate effectLst in shadow injection
PowerPoint flagged the deck for repair because shadow.inherit=False already
creates an empty <a:effectLst> and the code appended a second one, producing
invalid OOXML. Now reuse the existing effectLst. Validated: well-formed XML,
correct spPr child order, single effectLst per shape.

Co-Authored-By: Claude Opus 4.8 <noreply@anthropic.com>
Claude-Session: https://claude.ai/code/session_012tTcDHfUyc6kEEeDuXJ19L
</commit_message>
<xml_diff>
--- a/presentation/Presentation_PFE_ONMM.pptx
+++ b/presentation/Presentation_PFE_ONMM.pptx
@@ -5210,7 +5210,6 @@
           <a:ln>
             <a:noFill/>
           </a:ln>
-          <a:effectLst/>
           <a:effectLst>
             <a:outerShdw blurRad="90000" dist="40000" dir="5400000" rotWithShape="0">
               <a:srgbClr val="0A3D62">
@@ -6886,7 +6885,6 @@
               <a:srgbClr val="1B9AAA"/>
             </a:solidFill>
           </a:ln>
-          <a:effectLst/>
           <a:effectLst>
             <a:outerShdw blurRad="90000" dist="40000" dir="5400000" rotWithShape="0">
               <a:srgbClr val="0A3D62">
@@ -7099,7 +7097,6 @@
               <a:srgbClr val="0A3D62"/>
             </a:solidFill>
           </a:ln>
-          <a:effectLst/>
           <a:effectLst>
             <a:outerShdw blurRad="90000" dist="40000" dir="5400000" rotWithShape="0">
               <a:srgbClr val="0A3D62">
@@ -7312,7 +7309,6 @@
               <a:srgbClr val="2EC4B6"/>
             </a:solidFill>
           </a:ln>
-          <a:effectLst/>
           <a:effectLst>
             <a:outerShdw blurRad="90000" dist="40000" dir="5400000" rotWithShape="0">
               <a:srgbClr val="0A3D62">
@@ -7779,7 +7775,6 @@
               <a:srgbClr val="2EC4B6"/>
             </a:solidFill>
           </a:ln>
-          <a:effectLst/>
           <a:effectLst>
             <a:outerShdw blurRad="90000" dist="40000" dir="5400000" rotWithShape="0">
               <a:srgbClr val="0A3D62">
@@ -8004,7 +7999,6 @@
               <a:srgbClr val="0A3D62"/>
             </a:solidFill>
           </a:ln>
-          <a:effectLst/>
           <a:effectLst>
             <a:outerShdw blurRad="90000" dist="40000" dir="5400000" rotWithShape="0">
               <a:srgbClr val="0A3D62">
@@ -8229,7 +8223,6 @@
               <a:srgbClr val="1B9AAA"/>
             </a:solidFill>
           </a:ln>
-          <a:effectLst/>
           <a:effectLst>
             <a:outerShdw blurRad="90000" dist="40000" dir="5400000" rotWithShape="0">
               <a:srgbClr val="0A3D62">
@@ -8454,7 +8447,6 @@
               <a:srgbClr val="2EC4B6"/>
             </a:solidFill>
           </a:ln>
-          <a:effectLst/>
           <a:effectLst>
             <a:outerShdw blurRad="90000" dist="40000" dir="5400000" rotWithShape="0">
               <a:srgbClr val="0A3D62">
@@ -8679,7 +8671,6 @@
               <a:srgbClr val="0A3D62"/>
             </a:solidFill>
           </a:ln>
-          <a:effectLst/>
           <a:effectLst>
             <a:outerShdw blurRad="90000" dist="40000" dir="5400000" rotWithShape="0">
               <a:srgbClr val="0A3D62">
@@ -9340,7 +9331,6 @@
           <a:ln>
             <a:noFill/>
           </a:ln>
-          <a:effectLst/>
           <a:effectLst>
             <a:outerShdw blurRad="90000" dist="40000" dir="5400000" rotWithShape="0">
               <a:srgbClr val="0A3D62">
@@ -9636,7 +9626,6 @@
           <a:ln>
             <a:noFill/>
           </a:ln>
-          <a:effectLst/>
           <a:effectLst>
             <a:outerShdw blurRad="90000" dist="40000" dir="5400000" rotWithShape="0">
               <a:srgbClr val="0A3D62">
@@ -9920,7 +9909,6 @@
           <a:ln>
             <a:noFill/>
           </a:ln>
-          <a:effectLst/>
           <a:effectLst>
             <a:outerShdw blurRad="90000" dist="40000" dir="5400000" rotWithShape="0">
               <a:srgbClr val="0A3D62">
@@ -12024,7 +12012,6 @@
           <a:ln>
             <a:noFill/>
           </a:ln>
-          <a:effectLst/>
           <a:effectLst>
             <a:outerShdw blurRad="90000" dist="40000" dir="5400000" rotWithShape="0">
               <a:srgbClr val="0A3D62">
@@ -12230,7 +12217,6 @@
           <a:ln>
             <a:noFill/>
           </a:ln>
-          <a:effectLst/>
           <a:effectLst>
             <a:outerShdw blurRad="90000" dist="40000" dir="5400000" rotWithShape="0">
               <a:srgbClr val="0A3D62">
@@ -12436,7 +12422,6 @@
           <a:ln>
             <a:noFill/>
           </a:ln>
-          <a:effectLst/>
           <a:effectLst>
             <a:outerShdw blurRad="90000" dist="40000" dir="5400000" rotWithShape="0">
               <a:srgbClr val="0A3D62">
@@ -12642,7 +12627,6 @@
           <a:ln>
             <a:noFill/>
           </a:ln>
-          <a:effectLst/>
           <a:effectLst>
             <a:outerShdw blurRad="90000" dist="40000" dir="5400000" rotWithShape="0">
               <a:srgbClr val="0A3D62">
@@ -12848,7 +12832,6 @@
           <a:ln>
             <a:noFill/>
           </a:ln>
-          <a:effectLst/>
           <a:effectLst>
             <a:outerShdw blurRad="90000" dist="40000" dir="5400000" rotWithShape="0">
               <a:srgbClr val="0A3D62">
@@ -13054,7 +13037,6 @@
           <a:ln>
             <a:noFill/>
           </a:ln>
-          <a:effectLst/>
           <a:effectLst>
             <a:outerShdw blurRad="90000" dist="40000" dir="5400000" rotWithShape="0">
               <a:srgbClr val="0A3D62">
@@ -13514,7 +13496,6 @@
           <a:ln>
             <a:noFill/>
           </a:ln>
-          <a:effectLst/>
           <a:effectLst>
             <a:outerShdw blurRad="90000" dist="40000" dir="5400000" rotWithShape="0">
               <a:srgbClr val="0A3D62">
@@ -13755,7 +13736,6 @@
           <a:ln>
             <a:noFill/>
           </a:ln>
-          <a:effectLst/>
           <a:effectLst>
             <a:outerShdw blurRad="90000" dist="40000" dir="5400000" rotWithShape="0">
               <a:srgbClr val="0A3D62">
@@ -13960,7 +13940,6 @@
           <a:ln>
             <a:noFill/>
           </a:ln>
-          <a:effectLst/>
           <a:effectLst>
             <a:outerShdw blurRad="90000" dist="40000" dir="5400000" rotWithShape="0">
               <a:srgbClr val="0A3D62">
@@ -15220,7 +15199,6 @@
           <a:ln>
             <a:noFill/>
           </a:ln>
-          <a:effectLst/>
           <a:effectLst>
             <a:outerShdw blurRad="90000" dist="40000" dir="5400000" rotWithShape="0">
               <a:srgbClr val="0A3D62">
@@ -15445,7 +15423,6 @@
           <a:ln>
             <a:noFill/>
           </a:ln>
-          <a:effectLst/>
           <a:effectLst>
             <a:outerShdw blurRad="90000" dist="40000" dir="5400000" rotWithShape="0">
               <a:srgbClr val="0A3D62">
@@ -15670,7 +15647,6 @@
           <a:ln>
             <a:noFill/>
           </a:ln>
-          <a:effectLst/>
           <a:effectLst>
             <a:outerShdw blurRad="90000" dist="40000" dir="5400000" rotWithShape="0">
               <a:srgbClr val="0A3D62">
@@ -15895,7 +15871,6 @@
           <a:ln>
             <a:noFill/>
           </a:ln>
-          <a:effectLst/>
           <a:effectLst>
             <a:outerShdw blurRad="90000" dist="40000" dir="5400000" rotWithShape="0">
               <a:srgbClr val="0A3D62">
@@ -16120,7 +16095,6 @@
           <a:ln>
             <a:noFill/>
           </a:ln>
-          <a:effectLst/>
           <a:effectLst>
             <a:outerShdw blurRad="90000" dist="40000" dir="5400000" rotWithShape="0">
               <a:srgbClr val="0A3D62">
@@ -16345,7 +16319,6 @@
           <a:ln>
             <a:noFill/>
           </a:ln>
-          <a:effectLst/>
           <a:effectLst>
             <a:outerShdw blurRad="90000" dist="40000" dir="5400000" rotWithShape="0">
               <a:srgbClr val="0A3D62">
@@ -17057,7 +17030,6 @@
           <a:ln>
             <a:noFill/>
           </a:ln>
-          <a:effectLst/>
           <a:effectLst>
             <a:outerShdw blurRad="90000" dist="40000" dir="5400000" rotWithShape="0">
               <a:srgbClr val="0A3D62">
@@ -17260,7 +17232,6 @@
           <a:ln>
             <a:noFill/>
           </a:ln>
-          <a:effectLst/>
           <a:effectLst>
             <a:outerShdw blurRad="90000" dist="40000" dir="5400000" rotWithShape="0">
               <a:srgbClr val="0A3D62">
@@ -17475,7 +17446,6 @@
           <a:ln>
             <a:noFill/>
           </a:ln>
-          <a:effectLst/>
           <a:effectLst>
             <a:outerShdw blurRad="90000" dist="40000" dir="5400000" rotWithShape="0">
               <a:srgbClr val="0A3D62">
@@ -20922,7 +20892,6 @@
           <a:ln>
             <a:noFill/>
           </a:ln>
-          <a:effectLst/>
           <a:effectLst>
             <a:outerShdw blurRad="90000" dist="40000" dir="5400000" rotWithShape="0">
               <a:srgbClr val="0A3D62">
@@ -21054,7 +21023,6 @@
           <a:ln>
             <a:noFill/>
           </a:ln>
-          <a:effectLst/>
           <a:effectLst>
             <a:outerShdw blurRad="90000" dist="40000" dir="5400000" rotWithShape="0">
               <a:srgbClr val="0A3D62">
@@ -21267,7 +21235,6 @@
           <a:ln>
             <a:noFill/>
           </a:ln>
-          <a:effectLst/>
           <a:effectLst>
             <a:outerShdw blurRad="90000" dist="40000" dir="5400000" rotWithShape="0">
               <a:srgbClr val="0A3D62">
@@ -21492,7 +21459,6 @@
           <a:ln>
             <a:noFill/>
           </a:ln>
-          <a:effectLst/>
           <a:effectLst>
             <a:outerShdw blurRad="90000" dist="40000" dir="5400000" rotWithShape="0">
               <a:srgbClr val="0A3D62">
@@ -21717,7 +21683,6 @@
           <a:ln>
             <a:noFill/>
           </a:ln>
-          <a:effectLst/>
           <a:effectLst>
             <a:outerShdw blurRad="90000" dist="40000" dir="5400000" rotWithShape="0">
               <a:srgbClr val="0A3D62">
@@ -22161,7 +22126,6 @@
           <a:ln>
             <a:noFill/>
           </a:ln>
-          <a:effectLst/>
           <a:effectLst>
             <a:outerShdw blurRad="90000" dist="40000" dir="5400000" rotWithShape="0">
               <a:srgbClr val="0A3D62">
@@ -22340,7 +22304,6 @@
           <a:ln>
             <a:noFill/>
           </a:ln>
-          <a:effectLst/>
           <a:effectLst>
             <a:outerShdw blurRad="90000" dist="40000" dir="5400000" rotWithShape="0">
               <a:srgbClr val="0A3D62">
@@ -22519,7 +22482,6 @@
           <a:ln>
             <a:noFill/>
           </a:ln>
-          <a:effectLst/>
           <a:effectLst>
             <a:outerShdw blurRad="90000" dist="40000" dir="5400000" rotWithShape="0">
               <a:srgbClr val="0A3D62">
@@ -23524,7 +23486,6 @@
           <a:ln>
             <a:noFill/>
           </a:ln>
-          <a:effectLst/>
           <a:effectLst>
             <a:outerShdw blurRad="90000" dist="40000" dir="5400000" rotWithShape="0">
               <a:srgbClr val="0A3D62">
@@ -24282,7 +24243,6 @@
           <a:ln>
             <a:noFill/>
           </a:ln>
-          <a:effectLst/>
           <a:effectLst>
             <a:outerShdw blurRad="90000" dist="40000" dir="5400000" rotWithShape="0">
               <a:srgbClr val="0A3D62">
@@ -24790,7 +24750,6 @@
           <a:ln>
             <a:noFill/>
           </a:ln>
-          <a:effectLst/>
           <a:effectLst>
             <a:outerShdw blurRad="90000" dist="40000" dir="5400000" rotWithShape="0">
               <a:srgbClr val="0A3D62">
@@ -24995,7 +24954,6 @@
           <a:ln>
             <a:noFill/>
           </a:ln>
-          <a:effectLst/>
           <a:effectLst>
             <a:outerShdw blurRad="90000" dist="40000" dir="5400000" rotWithShape="0">
               <a:srgbClr val="0A3D62">
@@ -25200,7 +25158,6 @@
           <a:ln>
             <a:noFill/>
           </a:ln>
-          <a:effectLst/>
           <a:effectLst>
             <a:outerShdw blurRad="90000" dist="40000" dir="5400000" rotWithShape="0">
               <a:srgbClr val="0A3D62">

</xml_diff>